<commit_message>
feat(backend): enhance certificate submission and initialization workflow
- Add Google Sheets credentials and certificates database files to .gitignore
- Update backend BASE_URL to localhost for local testing
- Introduce database initialization on FastAPI startup event with logging
- Add email verification against Google Forms and prevent duplicate certificate generation
- Extend certificate submission with social link and store submission details in database
- Add endpoint to check certificate existence by email with detailed response
- Refactor certificate generation output directory path to absolute backend/static path
- Improve PDF conversion with LibreOffice including output directory and validation
- Dynamically detect and set Tesseract OCR executable path for cross-platform compatibility
- Implement delete_uploaded_file function to remove temporary upload files after processing
- Update frontend dependencies in package-lock.json with added packages and cleanup
</commit_message>
<xml_diff>
--- a/backend/static/certificates/Template of Certificate Intelligo.pptx
+++ b/backend/static/certificates/Template of Certificate Intelligo.pptx
@@ -14,29 +14,22 @@
   <p:notesSz cx="6858000" cy="9144000"/>
   <p:embeddedFontLst>
     <p:embeddedFont>
-      <p:font typeface="Playfair Display" panose="020F0502020204030204" pitchFamily="2" charset="0"/>
+      <p:font typeface="Playfair Display" panose="00000500000000000000" pitchFamily="2" charset="0"/>
       <p:regular r:id="rId4"/>
       <p:bold r:id="rId5"/>
       <p:italic r:id="rId6"/>
       <p:boldItalic r:id="rId7"/>
     </p:embeddedFont>
     <p:embeddedFont>
-      <p:font typeface="Plus Jakarta Sans" panose="020B0604020202020204" charset="0"/>
+      <p:font typeface="Poppins" panose="00000500000000000000" pitchFamily="2" charset="0"/>
       <p:regular r:id="rId8"/>
       <p:bold r:id="rId9"/>
       <p:italic r:id="rId10"/>
       <p:boldItalic r:id="rId11"/>
     </p:embeddedFont>
     <p:embeddedFont>
-      <p:font typeface="Poppins" panose="00000500000000000000" pitchFamily="2" charset="0"/>
+      <p:font typeface="Source Sans Pro" panose="020B0503030403020204" pitchFamily="34" charset="0"/>
       <p:regular r:id="rId12"/>
-      <p:bold r:id="rId13"/>
-      <p:italic r:id="rId14"/>
-      <p:boldItalic r:id="rId15"/>
-    </p:embeddedFont>
-    <p:embeddedFont>
-      <p:font typeface="Source Sans Pro" panose="020B0503030403020204" pitchFamily="34" charset="0"/>
-      <p:regular r:id="rId16"/>
     </p:embeddedFont>
   </p:embeddedFontLst>
   <p:defaultTextStyle>
@@ -5606,9 +5599,9 @@
         </p:nvGrpSpPr>
         <p:grpSpPr>
           <a:xfrm>
-            <a:off x="0" y="523"/>
+            <a:off x="-25003" y="0"/>
             <a:ext cx="9194006" cy="6857724"/>
-            <a:chOff x="0" y="0"/>
+            <a:chOff x="-76932" y="-804"/>
             <a:chExt cx="28289249" cy="19987538"/>
           </a:xfrm>
         </p:grpSpPr>
@@ -5628,7 +5621,7 @@
           </p:blipFill>
           <p:spPr>
             <a:xfrm>
-              <a:off x="0" y="0"/>
+              <a:off x="-76932" y="-804"/>
               <a:ext cx="28289249" cy="19987538"/>
             </a:xfrm>
             <a:prstGeom prst="rect">
@@ -5851,110 +5844,6 @@
           </a:p>
         </p:txBody>
       </p:sp>
-      <p:sp>
-        <p:nvSpPr>
-          <p:cNvPr id="59" name="Google Shape;59;p13"/>
-          <p:cNvSpPr/>
-          <p:nvPr/>
-        </p:nvSpPr>
-        <p:spPr>
-          <a:xfrm>
-            <a:off x="350109" y="1445626"/>
-            <a:ext cx="4363500" cy="532800"/>
-          </a:xfrm>
-          <a:prstGeom prst="rect">
-            <a:avLst/>
-          </a:prstGeom>
-          <a:solidFill>
-            <a:srgbClr val="FF4500"/>
-          </a:solidFill>
-          <a:ln w="3150" cap="flat" cmpd="sng">
-            <a:solidFill>
-              <a:srgbClr val="FF4500"/>
-            </a:solidFill>
-            <a:prstDash val="solid"/>
-            <a:round/>
-            <a:headEnd type="none" w="sm" len="sm"/>
-            <a:tailEnd type="none" w="sm" len="sm"/>
-          </a:ln>
-        </p:spPr>
-        <p:txBody>
-          <a:bodyPr spcFirstLastPara="1" wrap="square" lIns="30150" tIns="30150" rIns="30150" bIns="30150" anchor="ctr" anchorCtr="0">
-            <a:noAutofit/>
-          </a:bodyPr>
-          <a:lstStyle/>
-          <a:p>
-            <a:pPr marL="0" lvl="0" indent="0" algn="ctr" rtl="0">
-              <a:spcBef>
-                <a:spcPts val="0"/>
-              </a:spcBef>
-              <a:spcAft>
-                <a:spcPts val="0"/>
-              </a:spcAft>
-              <a:buNone/>
-            </a:pPr>
-            <a:endParaRPr sz="462"/>
-          </a:p>
-        </p:txBody>
-      </p:sp>
-      <p:sp>
-        <p:nvSpPr>
-          <p:cNvPr id="60" name="Google Shape;60;p13"/>
-          <p:cNvSpPr txBox="1"/>
-          <p:nvPr/>
-        </p:nvSpPr>
-        <p:spPr>
-          <a:xfrm>
-            <a:off x="465956" y="1445626"/>
-            <a:ext cx="5573400" cy="532800"/>
-          </a:xfrm>
-          <a:prstGeom prst="rect">
-            <a:avLst/>
-          </a:prstGeom>
-          <a:noFill/>
-          <a:ln>
-            <a:noFill/>
-          </a:ln>
-        </p:spPr>
-        <p:txBody>
-          <a:bodyPr spcFirstLastPara="1" wrap="square" lIns="30150" tIns="30150" rIns="30150" bIns="30150" anchor="t" anchorCtr="0">
-            <a:noAutofit/>
-          </a:bodyPr>
-          <a:lstStyle/>
-          <a:p>
-            <a:pPr marL="0" lvl="0" indent="0" algn="l" rtl="0">
-              <a:spcBef>
-                <a:spcPts val="0"/>
-              </a:spcBef>
-              <a:spcAft>
-                <a:spcPts val="0"/>
-              </a:spcAft>
-              <a:buNone/>
-            </a:pPr>
-            <a:r>
-              <a:rPr lang="en" sz="3166" dirty="0">
-                <a:solidFill>
-                  <a:schemeClr val="lt1"/>
-                </a:solidFill>
-                <a:latin typeface="Plus Jakarta Sans"/>
-                <a:ea typeface="Plus Jakarta Sans"/>
-                <a:cs typeface="Plus Jakarta Sans"/>
-                <a:sym typeface="Plus Jakarta Sans"/>
-              </a:rPr>
-              <a:t>O F   PARTICIPANT</a:t>
-            </a:r>
-            <a:endParaRPr sz="3166" dirty="0">
-              <a:solidFill>
-                <a:schemeClr val="lt1"/>
-              </a:solidFill>
-              <a:latin typeface="Plus Jakarta Sans"/>
-              <a:ea typeface="Plus Jakarta Sans"/>
-              <a:cs typeface="Plus Jakarta Sans"/>
-              <a:sym typeface="Plus Jakarta Sans"/>
-            </a:endParaRPr>
-          </a:p>
-        </p:txBody>
-      </p:sp>
       <p:cxnSp>
         <p:nvCxnSpPr>
           <p:cNvPr id="61" name="Google Shape;61;p13"/>
@@ -6042,7 +5931,7 @@
               <a:buNone/>
             </a:pPr>
             <a:r>
-              <a:rPr lang="en" sz="3200" b="1">
+              <a:rPr lang="en" sz="3200" b="1" dirty="0">
                 <a:solidFill>
                   <a:schemeClr val="dk1"/>
                 </a:solidFill>
@@ -6053,7 +5942,7 @@
               </a:rPr>
               <a:t>{{NAMA}}</a:t>
             </a:r>
-            <a:endParaRPr sz="3200" b="1">
+            <a:endParaRPr sz="3200" b="1" dirty="0">
               <a:solidFill>
                 <a:schemeClr val="dk1"/>
               </a:solidFill>
@@ -6065,33 +5954,6 @@
           </a:p>
         </p:txBody>
       </p:sp>
-      <p:pic>
-        <p:nvPicPr>
-          <p:cNvPr id="64" name="Google Shape;64;p13" title="Intelligo.Id_Main Logo Ver.jpg"/>
-          <p:cNvPicPr preferRelativeResize="0"/>
-          <p:nvPr/>
-        </p:nvPicPr>
-        <p:blipFill rotWithShape="1">
-          <a:blip r:embed="rId4">
-            <a:alphaModFix/>
-          </a:blip>
-          <a:srcRect l="29680" t="34342" r="30679" b="32989"/>
-          <a:stretch/>
-        </p:blipFill>
-        <p:spPr>
-          <a:xfrm>
-            <a:off x="7667375" y="1829075"/>
-            <a:ext cx="1067827" cy="880026"/>
-          </a:xfrm>
-          <a:prstGeom prst="rect">
-            <a:avLst/>
-          </a:prstGeom>
-          <a:noFill/>
-          <a:ln>
-            <a:noFill/>
-          </a:ln>
-        </p:spPr>
-      </p:pic>
       <p:sp>
         <p:nvSpPr>
           <p:cNvPr id="65" name="Google Shape;65;p13"/>
@@ -6245,7 +6107,7 @@
           <p:nvPr/>
         </p:nvPicPr>
         <p:blipFill>
-          <a:blip r:embed="rId5">
+          <a:blip r:embed="rId4">
             <a:alphaModFix/>
           </a:blip>
           <a:stretch>
@@ -6301,7 +6163,7 @@
               <a:buNone/>
             </a:pPr>
             <a:r>
-              <a:rPr lang="en" sz="1200" b="1">
+              <a:rPr lang="en" sz="1200" b="1" dirty="0">
                 <a:solidFill>
                   <a:schemeClr val="dk1"/>
                 </a:solidFill>
@@ -6315,7 +6177,7 @@
               </a:rPr>
               <a:t>Muhammad Fahmi</a:t>
             </a:r>
-            <a:endParaRPr sz="1200" b="1">
+            <a:endParaRPr sz="1200" b="1" dirty="0">
               <a:solidFill>
                 <a:schemeClr val="dk1"/>
               </a:solidFill>
@@ -6339,7 +6201,7 @@
               <a:buNone/>
             </a:pPr>
             <a:r>
-              <a:rPr lang="en" sz="1200">
+              <a:rPr lang="en" sz="1200" dirty="0">
                 <a:solidFill>
                   <a:schemeClr val="dk1"/>
                 </a:solidFill>
@@ -6353,7 +6215,7 @@
               </a:rPr>
               <a:t>Head of Learning</a:t>
             </a:r>
-            <a:endParaRPr sz="1200">
+            <a:endParaRPr sz="1200" dirty="0">
               <a:solidFill>
                 <a:schemeClr val="dk1"/>
               </a:solidFill>

</xml_diff>